<commit_message>
chore(tinder): nettoyage complet du dossier assets pour ne conserver que les 5 visuels cles corriges
</commit_message>
<xml_diff>
--- a/Bloc_2_Analyse_Exploratoire/Tinder/Tinder_presentation.pptx
+++ b/Bloc_2_Analyse_Exploratoire/Tinder/Tinder_presentation.pptx
@@ -271,7 +271,7 @@
   </p:defaultTextStyle>
   <p:extLst>
     <p:ext uri="GoogleSlidesCustomDataVersion2">
-      <go:slidesCustomData xmlns:go="http://customooxmlschemas.google.com/" r:id="rId23" roundtripDataSignature="AMtx7mjvHh0GhaJmvMs4vKR6wNNCHPQXwA=="/>
+      <go:slidesCustomData xmlns:go="http://customooxmlschemas.google.com/" r:id="rId23" roundtripDataSignature="AMtx7mg5APeFNvRUeYeaiuYcqxSyDkHhNQ=="/>
     </p:ext>
   </p:extLst>
 </p:presentation>
@@ -1341,7 +1341,7 @@
   <p:cSld>
     <p:spTree>
       <p:nvGrpSpPr>
-        <p:cNvPr id="72" name="Shape 72"/>
+        <p:cNvPr id="71" name="Shape 71"/>
         <p:cNvGrpSpPr/>
         <p:nvPr/>
       </p:nvGrpSpPr>
@@ -1355,7 +1355,7 @@
       </p:grpSpPr>
       <p:sp>
         <p:nvSpPr>
-          <p:cNvPr id="73" name="Google Shape;73;p4:notes"/>
+          <p:cNvPr id="72" name="Google Shape;72;p4:notes"/>
           <p:cNvSpPr/>
           <p:nvPr>
             <p:ph idx="2" type="sldImg"/>
@@ -1394,7 +1394,7 @@
       </p:sp>
       <p:sp>
         <p:nvSpPr>
-          <p:cNvPr id="74" name="Google Shape;74;p4:notes"/>
+          <p:cNvPr id="73" name="Google Shape;73;p4:notes"/>
           <p:cNvSpPr txBox="1"/>
           <p:nvPr>
             <p:ph idx="1" type="body"/>
@@ -1449,7 +1449,7 @@
       </p:sp>
       <p:sp>
         <p:nvSpPr>
-          <p:cNvPr id="75" name="Google Shape;75;p4:notes"/>
+          <p:cNvPr id="74" name="Google Shape;74;p4:notes"/>
           <p:cNvSpPr txBox="1"/>
           <p:nvPr>
             <p:ph idx="12" type="sldNum"/>
@@ -1528,7 +1528,7 @@
   <p:cSld>
     <p:spTree>
       <p:nvGrpSpPr>
-        <p:cNvPr id="94" name="Shape 94"/>
+        <p:cNvPr id="93" name="Shape 93"/>
         <p:cNvGrpSpPr/>
         <p:nvPr/>
       </p:nvGrpSpPr>
@@ -1542,7 +1542,7 @@
       </p:grpSpPr>
       <p:sp>
         <p:nvSpPr>
-          <p:cNvPr id="95" name="Google Shape;95;p5:notes"/>
+          <p:cNvPr id="94" name="Google Shape;94;p5:notes"/>
           <p:cNvSpPr/>
           <p:nvPr>
             <p:ph idx="2" type="sldImg"/>
@@ -1581,7 +1581,7 @@
       </p:sp>
       <p:sp>
         <p:nvSpPr>
-          <p:cNvPr id="96" name="Google Shape;96;p5:notes"/>
+          <p:cNvPr id="95" name="Google Shape;95;p5:notes"/>
           <p:cNvSpPr txBox="1"/>
           <p:nvPr>
             <p:ph idx="1" type="body"/>
@@ -1636,7 +1636,7 @@
       </p:sp>
       <p:sp>
         <p:nvSpPr>
-          <p:cNvPr id="97" name="Google Shape;97;p5:notes"/>
+          <p:cNvPr id="96" name="Google Shape;96;p5:notes"/>
           <p:cNvSpPr txBox="1"/>
           <p:nvPr>
             <p:ph idx="12" type="sldNum"/>
@@ -1715,7 +1715,7 @@
   <p:cSld>
     <p:spTree>
       <p:nvGrpSpPr>
-        <p:cNvPr id="111" name="Shape 111"/>
+        <p:cNvPr id="110" name="Shape 110"/>
         <p:cNvGrpSpPr/>
         <p:nvPr/>
       </p:nvGrpSpPr>
@@ -1729,7 +1729,7 @@
       </p:grpSpPr>
       <p:sp>
         <p:nvSpPr>
-          <p:cNvPr id="112" name="Google Shape;112;p6:notes"/>
+          <p:cNvPr id="111" name="Google Shape;111;p6:notes"/>
           <p:cNvSpPr/>
           <p:nvPr>
             <p:ph idx="2" type="sldImg"/>
@@ -1768,7 +1768,7 @@
       </p:sp>
       <p:sp>
         <p:nvSpPr>
-          <p:cNvPr id="113" name="Google Shape;113;p6:notes"/>
+          <p:cNvPr id="112" name="Google Shape;112;p6:notes"/>
           <p:cNvSpPr txBox="1"/>
           <p:nvPr>
             <p:ph idx="1" type="body"/>
@@ -1823,7 +1823,7 @@
       </p:sp>
       <p:sp>
         <p:nvSpPr>
-          <p:cNvPr id="114" name="Google Shape;114;p6:notes"/>
+          <p:cNvPr id="113" name="Google Shape;113;p6:notes"/>
           <p:cNvSpPr txBox="1"/>
           <p:nvPr>
             <p:ph idx="12" type="sldNum"/>
@@ -1902,7 +1902,7 @@
   <p:cSld>
     <p:spTree>
       <p:nvGrpSpPr>
-        <p:cNvPr id="130" name="Shape 130"/>
+        <p:cNvPr id="129" name="Shape 129"/>
         <p:cNvGrpSpPr/>
         <p:nvPr/>
       </p:nvGrpSpPr>
@@ -1916,7 +1916,7 @@
       </p:grpSpPr>
       <p:sp>
         <p:nvSpPr>
-          <p:cNvPr id="131" name="Google Shape;131;p7:notes"/>
+          <p:cNvPr id="130" name="Google Shape;130;p7:notes"/>
           <p:cNvSpPr/>
           <p:nvPr>
             <p:ph idx="2" type="sldImg"/>
@@ -1955,7 +1955,7 @@
       </p:sp>
       <p:sp>
         <p:nvSpPr>
-          <p:cNvPr id="132" name="Google Shape;132;p7:notes"/>
+          <p:cNvPr id="131" name="Google Shape;131;p7:notes"/>
           <p:cNvSpPr txBox="1"/>
           <p:nvPr>
             <p:ph idx="1" type="body"/>
@@ -2010,7 +2010,7 @@
       </p:sp>
       <p:sp>
         <p:nvSpPr>
-          <p:cNvPr id="133" name="Google Shape;133;p7:notes"/>
+          <p:cNvPr id="132" name="Google Shape;132;p7:notes"/>
           <p:cNvSpPr txBox="1"/>
           <p:nvPr>
             <p:ph idx="12" type="sldNum"/>
@@ -2089,7 +2089,7 @@
   <p:cSld>
     <p:spTree>
       <p:nvGrpSpPr>
-        <p:cNvPr id="146" name="Shape 146"/>
+        <p:cNvPr id="145" name="Shape 145"/>
         <p:cNvGrpSpPr/>
         <p:nvPr/>
       </p:nvGrpSpPr>
@@ -2103,7 +2103,7 @@
       </p:grpSpPr>
       <p:sp>
         <p:nvSpPr>
-          <p:cNvPr id="147" name="Google Shape;147;p8:notes"/>
+          <p:cNvPr id="146" name="Google Shape;146;p8:notes"/>
           <p:cNvSpPr/>
           <p:nvPr>
             <p:ph idx="2" type="sldImg"/>
@@ -2142,7 +2142,7 @@
       </p:sp>
       <p:sp>
         <p:nvSpPr>
-          <p:cNvPr id="148" name="Google Shape;148;p8:notes"/>
+          <p:cNvPr id="147" name="Google Shape;147;p8:notes"/>
           <p:cNvSpPr txBox="1"/>
           <p:nvPr>
             <p:ph idx="1" type="body"/>
@@ -2197,7 +2197,7 @@
       </p:sp>
       <p:sp>
         <p:nvSpPr>
-          <p:cNvPr id="149" name="Google Shape;149;p8:notes"/>
+          <p:cNvPr id="148" name="Google Shape;148;p8:notes"/>
           <p:cNvSpPr txBox="1"/>
           <p:nvPr>
             <p:ph idx="12" type="sldNum"/>
@@ -5991,36 +5991,9 @@
           </a:p>
         </p:txBody>
       </p:sp>
-      <p:pic>
-        <p:nvPicPr>
-          <p:cNvPr id="60" name="Google Shape;60;p3"/>
-          <p:cNvPicPr preferRelativeResize="0"/>
-          <p:nvPr/>
-        </p:nvPicPr>
-        <p:blipFill rotWithShape="1">
-          <a:blip r:embed="rId4">
-            <a:alphaModFix/>
-          </a:blip>
-          <a:srcRect b="100" l="0" r="0" t="100"/>
-          <a:stretch/>
-        </p:blipFill>
-        <p:spPr>
-          <a:xfrm>
-            <a:off x="152400" y="1085850"/>
-            <a:ext cx="5667300" cy="2800500"/>
-          </a:xfrm>
-          <a:prstGeom prst="rect">
-            <a:avLst/>
-          </a:prstGeom>
-          <a:noFill/>
-          <a:ln>
-            <a:noFill/>
-          </a:ln>
-        </p:spPr>
-      </p:pic>
       <p:grpSp>
         <p:nvGrpSpPr>
-          <p:cNvPr id="61" name="Google Shape;61;p3"/>
+          <p:cNvPr id="60" name="Google Shape;60;p3"/>
           <p:cNvGrpSpPr/>
           <p:nvPr/>
         </p:nvGrpSpPr>
@@ -6034,7 +6007,7 @@
         </p:grpSpPr>
         <p:sp>
           <p:nvSpPr>
-            <p:cNvPr id="62" name="Google Shape;62;p3"/>
+            <p:cNvPr id="61" name="Google Shape;61;p3"/>
             <p:cNvSpPr/>
             <p:nvPr/>
           </p:nvSpPr>
@@ -6101,7 +6074,7 @@
         </p:sp>
         <p:sp>
           <p:nvSpPr>
-            <p:cNvPr id="63" name="Google Shape;63;p3"/>
+            <p:cNvPr id="62" name="Google Shape;62;p3"/>
             <p:cNvSpPr txBox="1"/>
             <p:nvPr/>
           </p:nvSpPr>
@@ -6232,7 +6205,7 @@
       </p:grpSp>
       <p:grpSp>
         <p:nvGrpSpPr>
-          <p:cNvPr id="64" name="Google Shape;64;p3"/>
+          <p:cNvPr id="63" name="Google Shape;63;p3"/>
           <p:cNvGrpSpPr/>
           <p:nvPr/>
         </p:nvGrpSpPr>
@@ -6246,7 +6219,7 @@
         </p:grpSpPr>
         <p:sp>
           <p:nvSpPr>
-            <p:cNvPr id="65" name="Google Shape;65;p3"/>
+            <p:cNvPr id="64" name="Google Shape;64;p3"/>
             <p:cNvSpPr/>
             <p:nvPr/>
           </p:nvSpPr>
@@ -6313,7 +6286,7 @@
         </p:sp>
         <p:sp>
           <p:nvSpPr>
-            <p:cNvPr id="66" name="Google Shape;66;p3"/>
+            <p:cNvPr id="65" name="Google Shape;65;p3"/>
             <p:cNvSpPr txBox="1"/>
             <p:nvPr/>
           </p:nvSpPr>
@@ -6444,7 +6417,7 @@
       </p:grpSp>
       <p:grpSp>
         <p:nvGrpSpPr>
-          <p:cNvPr id="67" name="Google Shape;67;p3"/>
+          <p:cNvPr id="66" name="Google Shape;66;p3"/>
           <p:cNvGrpSpPr/>
           <p:nvPr/>
         </p:nvGrpSpPr>
@@ -6458,7 +6431,7 @@
         </p:grpSpPr>
         <p:sp>
           <p:nvSpPr>
-            <p:cNvPr id="68" name="Google Shape;68;p3"/>
+            <p:cNvPr id="67" name="Google Shape;67;p3"/>
             <p:cNvSpPr/>
             <p:nvPr/>
           </p:nvSpPr>
@@ -6525,7 +6498,7 @@
         </p:sp>
         <p:sp>
           <p:nvSpPr>
-            <p:cNvPr id="69" name="Google Shape;69;p3"/>
+            <p:cNvPr id="68" name="Google Shape;68;p3"/>
             <p:cNvSpPr txBox="1"/>
             <p:nvPr/>
           </p:nvSpPr>
@@ -6656,7 +6629,7 @@
       </p:grpSp>
       <p:sp>
         <p:nvSpPr>
-          <p:cNvPr id="70" name="Google Shape;70;p3"/>
+          <p:cNvPr id="69" name="Google Shape;69;p3"/>
           <p:cNvSpPr/>
           <p:nvPr/>
         </p:nvSpPr>
@@ -6723,7 +6696,7 @@
       </p:sp>
       <p:sp>
         <p:nvSpPr>
-          <p:cNvPr id="71" name="Google Shape;71;p3"/>
+          <p:cNvPr id="70" name="Google Shape;70;p3"/>
           <p:cNvSpPr txBox="1"/>
           <p:nvPr/>
         </p:nvSpPr>
@@ -6819,7 +6792,7 @@
     </p:bg>
     <p:spTree>
       <p:nvGrpSpPr>
-        <p:cNvPr id="76" name="Shape 76"/>
+        <p:cNvPr id="75" name="Shape 75"/>
         <p:cNvGrpSpPr/>
         <p:nvPr/>
       </p:nvGrpSpPr>
@@ -6833,7 +6806,7 @@
       </p:grpSpPr>
       <p:pic>
         <p:nvPicPr>
-          <p:cNvPr descr="assets/logo_mark.png" id="77" name="Google Shape;77;p4"/>
+          <p:cNvPr descr="assets/logo_mark.png" id="76" name="Google Shape;76;p4"/>
           <p:cNvPicPr preferRelativeResize="0"/>
           <p:nvPr/>
         </p:nvPicPr>
@@ -6860,7 +6833,7 @@
       </p:pic>
       <p:pic>
         <p:nvPicPr>
-          <p:cNvPr id="78" name="Google Shape;78;p4"/>
+          <p:cNvPr id="77" name="Google Shape;77;p4"/>
           <p:cNvPicPr preferRelativeResize="0"/>
           <p:nvPr/>
         </p:nvPicPr>
@@ -6887,7 +6860,7 @@
       </p:pic>
       <p:sp>
         <p:nvSpPr>
-          <p:cNvPr id="79" name="Google Shape;79;p4"/>
+          <p:cNvPr id="78" name="Google Shape;78;p4"/>
           <p:cNvSpPr/>
           <p:nvPr/>
         </p:nvSpPr>
@@ -6953,7 +6926,7 @@
       </p:sp>
       <p:sp>
         <p:nvSpPr>
-          <p:cNvPr id="80" name="Google Shape;80;p4"/>
+          <p:cNvPr id="79" name="Google Shape;79;p4"/>
           <p:cNvSpPr/>
           <p:nvPr/>
         </p:nvSpPr>
@@ -7018,7 +6991,7 @@
       </p:sp>
       <p:sp>
         <p:nvSpPr>
-          <p:cNvPr id="81" name="Google Shape;81;p4"/>
+          <p:cNvPr id="80" name="Google Shape;80;p4"/>
           <p:cNvSpPr txBox="1"/>
           <p:nvPr/>
         </p:nvSpPr>
@@ -7084,7 +7057,7 @@
       </p:sp>
       <p:grpSp>
         <p:nvGrpSpPr>
-          <p:cNvPr id="82" name="Google Shape;82;p4"/>
+          <p:cNvPr id="81" name="Google Shape;81;p4"/>
           <p:cNvGrpSpPr/>
           <p:nvPr/>
         </p:nvGrpSpPr>
@@ -7098,7 +7071,7 @@
         </p:grpSpPr>
         <p:sp>
           <p:nvSpPr>
-            <p:cNvPr id="83" name="Google Shape;83;p4"/>
+            <p:cNvPr id="82" name="Google Shape;82;p4"/>
             <p:cNvSpPr/>
             <p:nvPr/>
           </p:nvSpPr>
@@ -7165,7 +7138,7 @@
         </p:sp>
         <p:sp>
           <p:nvSpPr>
-            <p:cNvPr id="84" name="Google Shape;84;p4"/>
+            <p:cNvPr id="83" name="Google Shape;83;p4"/>
             <p:cNvSpPr txBox="1"/>
             <p:nvPr/>
           </p:nvSpPr>
@@ -7272,7 +7245,7 @@
       </p:grpSp>
       <p:grpSp>
         <p:nvGrpSpPr>
-          <p:cNvPr id="85" name="Google Shape;85;p4"/>
+          <p:cNvPr id="84" name="Google Shape;84;p4"/>
           <p:cNvGrpSpPr/>
           <p:nvPr/>
         </p:nvGrpSpPr>
@@ -7286,7 +7259,7 @@
         </p:grpSpPr>
         <p:sp>
           <p:nvSpPr>
-            <p:cNvPr id="86" name="Google Shape;86;p4"/>
+            <p:cNvPr id="85" name="Google Shape;85;p4"/>
             <p:cNvSpPr/>
             <p:nvPr/>
           </p:nvSpPr>
@@ -7353,7 +7326,7 @@
         </p:sp>
         <p:sp>
           <p:nvSpPr>
-            <p:cNvPr id="87" name="Google Shape;87;p4"/>
+            <p:cNvPr id="86" name="Google Shape;86;p4"/>
             <p:cNvSpPr txBox="1"/>
             <p:nvPr/>
           </p:nvSpPr>
@@ -7508,7 +7481,7 @@
       </p:grpSp>
       <p:grpSp>
         <p:nvGrpSpPr>
-          <p:cNvPr id="88" name="Google Shape;88;p4"/>
+          <p:cNvPr id="87" name="Google Shape;87;p4"/>
           <p:cNvGrpSpPr/>
           <p:nvPr/>
         </p:nvGrpSpPr>
@@ -7522,7 +7495,7 @@
         </p:grpSpPr>
         <p:sp>
           <p:nvSpPr>
-            <p:cNvPr id="89" name="Google Shape;89;p4"/>
+            <p:cNvPr id="88" name="Google Shape;88;p4"/>
             <p:cNvSpPr/>
             <p:nvPr/>
           </p:nvSpPr>
@@ -7589,7 +7562,7 @@
         </p:sp>
         <p:sp>
           <p:nvSpPr>
-            <p:cNvPr id="90" name="Google Shape;90;p4"/>
+            <p:cNvPr id="89" name="Google Shape;89;p4"/>
             <p:cNvSpPr txBox="1"/>
             <p:nvPr/>
           </p:nvSpPr>
@@ -7696,7 +7669,7 @@
       </p:grpSp>
       <p:grpSp>
         <p:nvGrpSpPr>
-          <p:cNvPr id="91" name="Google Shape;91;p4"/>
+          <p:cNvPr id="90" name="Google Shape;90;p4"/>
           <p:cNvGrpSpPr/>
           <p:nvPr/>
         </p:nvGrpSpPr>
@@ -7710,7 +7683,7 @@
         </p:grpSpPr>
         <p:sp>
           <p:nvSpPr>
-            <p:cNvPr id="92" name="Google Shape;92;p4"/>
+            <p:cNvPr id="91" name="Google Shape;91;p4"/>
             <p:cNvSpPr/>
             <p:nvPr/>
           </p:nvSpPr>
@@ -7777,7 +7750,7 @@
         </p:sp>
         <p:sp>
           <p:nvSpPr>
-            <p:cNvPr id="93" name="Google Shape;93;p4"/>
+            <p:cNvPr id="92" name="Google Shape;92;p4"/>
             <p:cNvSpPr txBox="1"/>
             <p:nvPr/>
           </p:nvSpPr>
@@ -7874,7 +7847,7 @@
     </p:bg>
     <p:spTree>
       <p:nvGrpSpPr>
-        <p:cNvPr id="98" name="Shape 98"/>
+        <p:cNvPr id="97" name="Shape 97"/>
         <p:cNvGrpSpPr/>
         <p:nvPr/>
       </p:nvGrpSpPr>
@@ -7888,7 +7861,7 @@
       </p:grpSpPr>
       <p:pic>
         <p:nvPicPr>
-          <p:cNvPr descr="assets/logo_mark.png" id="99" name="Google Shape;99;p5"/>
+          <p:cNvPr descr="assets/logo_mark.png" id="98" name="Google Shape;98;p5"/>
           <p:cNvPicPr preferRelativeResize="0"/>
           <p:nvPr/>
         </p:nvPicPr>
@@ -7915,7 +7888,7 @@
       </p:pic>
       <p:sp>
         <p:nvSpPr>
-          <p:cNvPr id="100" name="Google Shape;100;p5"/>
+          <p:cNvPr id="99" name="Google Shape;99;p5"/>
           <p:cNvSpPr/>
           <p:nvPr/>
         </p:nvSpPr>
@@ -7981,7 +7954,7 @@
       </p:sp>
       <p:sp>
         <p:nvSpPr>
-          <p:cNvPr id="101" name="Google Shape;101;p5"/>
+          <p:cNvPr id="100" name="Google Shape;100;p5"/>
           <p:cNvSpPr/>
           <p:nvPr/>
         </p:nvSpPr>
@@ -8046,7 +8019,7 @@
       </p:sp>
       <p:grpSp>
         <p:nvGrpSpPr>
-          <p:cNvPr id="102" name="Google Shape;102;p5"/>
+          <p:cNvPr id="101" name="Google Shape;101;p5"/>
           <p:cNvGrpSpPr/>
           <p:nvPr/>
         </p:nvGrpSpPr>
@@ -8060,7 +8033,7 @@
         </p:grpSpPr>
         <p:sp>
           <p:nvSpPr>
-            <p:cNvPr id="103" name="Google Shape;103;p5"/>
+            <p:cNvPr id="102" name="Google Shape;102;p5"/>
             <p:cNvSpPr/>
             <p:nvPr/>
           </p:nvSpPr>
@@ -8127,7 +8100,7 @@
         </p:sp>
         <p:sp>
           <p:nvSpPr>
-            <p:cNvPr id="104" name="Google Shape;104;p5"/>
+            <p:cNvPr id="103" name="Google Shape;103;p5"/>
             <p:cNvSpPr txBox="1"/>
             <p:nvPr/>
           </p:nvSpPr>
@@ -8274,7 +8247,7 @@
       </p:grpSp>
       <p:grpSp>
         <p:nvGrpSpPr>
-          <p:cNvPr id="105" name="Google Shape;105;p5"/>
+          <p:cNvPr id="104" name="Google Shape;104;p5"/>
           <p:cNvGrpSpPr/>
           <p:nvPr/>
         </p:nvGrpSpPr>
@@ -8288,7 +8261,7 @@
         </p:grpSpPr>
         <p:sp>
           <p:nvSpPr>
-            <p:cNvPr id="106" name="Google Shape;106;p5"/>
+            <p:cNvPr id="105" name="Google Shape;105;p5"/>
             <p:cNvSpPr/>
             <p:nvPr/>
           </p:nvSpPr>
@@ -8355,7 +8328,7 @@
         </p:sp>
         <p:sp>
           <p:nvSpPr>
-            <p:cNvPr id="107" name="Google Shape;107;p5"/>
+            <p:cNvPr id="106" name="Google Shape;106;p5"/>
             <p:cNvSpPr txBox="1"/>
             <p:nvPr/>
           </p:nvSpPr>
@@ -8502,7 +8475,7 @@
       </p:grpSp>
       <p:sp>
         <p:nvSpPr>
-          <p:cNvPr id="108" name="Google Shape;108;p5"/>
+          <p:cNvPr id="107" name="Google Shape;107;p5"/>
           <p:cNvSpPr/>
           <p:nvPr/>
         </p:nvSpPr>
@@ -8569,7 +8542,7 @@
       </p:sp>
       <p:sp>
         <p:nvSpPr>
-          <p:cNvPr id="109" name="Google Shape;109;p5"/>
+          <p:cNvPr id="108" name="Google Shape;108;p5"/>
           <p:cNvSpPr txBox="1"/>
           <p:nvPr/>
         </p:nvSpPr>
@@ -8651,7 +8624,7 @@
       </p:sp>
       <p:pic>
         <p:nvPicPr>
-          <p:cNvPr id="110" name="Google Shape;110;p5"/>
+          <p:cNvPr id="109" name="Google Shape;109;p5"/>
           <p:cNvPicPr preferRelativeResize="0"/>
           <p:nvPr/>
         </p:nvPicPr>
@@ -8696,7 +8669,7 @@
     </p:bg>
     <p:spTree>
       <p:nvGrpSpPr>
-        <p:cNvPr id="115" name="Shape 115"/>
+        <p:cNvPr id="114" name="Shape 114"/>
         <p:cNvGrpSpPr/>
         <p:nvPr/>
       </p:nvGrpSpPr>
@@ -8710,7 +8683,7 @@
       </p:grpSpPr>
       <p:pic>
         <p:nvPicPr>
-          <p:cNvPr descr="assets/logo_mark.png" id="116" name="Google Shape;116;p6"/>
+          <p:cNvPr descr="assets/logo_mark.png" id="115" name="Google Shape;115;p6"/>
           <p:cNvPicPr preferRelativeResize="0"/>
           <p:nvPr/>
         </p:nvPicPr>
@@ -8737,7 +8710,7 @@
       </p:pic>
       <p:sp>
         <p:nvSpPr>
-          <p:cNvPr id="117" name="Google Shape;117;p6"/>
+          <p:cNvPr id="116" name="Google Shape;116;p6"/>
           <p:cNvSpPr/>
           <p:nvPr/>
         </p:nvSpPr>
@@ -8807,7 +8780,7 @@
       </p:sp>
       <p:sp>
         <p:nvSpPr>
-          <p:cNvPr id="118" name="Google Shape;118;p6"/>
+          <p:cNvPr id="117" name="Google Shape;117;p6"/>
           <p:cNvSpPr/>
           <p:nvPr/>
         </p:nvSpPr>
@@ -8872,7 +8845,7 @@
       </p:sp>
       <p:sp>
         <p:nvSpPr>
-          <p:cNvPr id="119" name="Google Shape;119;p6"/>
+          <p:cNvPr id="118" name="Google Shape;118;p6"/>
           <p:cNvSpPr/>
           <p:nvPr/>
         </p:nvSpPr>
@@ -8929,7 +8902,7 @@
       </p:sp>
       <p:pic>
         <p:nvPicPr>
-          <p:cNvPr id="120" name="Google Shape;120;p6"/>
+          <p:cNvPr id="119" name="Google Shape;119;p6"/>
           <p:cNvPicPr preferRelativeResize="0"/>
           <p:nvPr/>
         </p:nvPicPr>
@@ -8956,7 +8929,7 @@
       </p:pic>
       <p:grpSp>
         <p:nvGrpSpPr>
-          <p:cNvPr id="121" name="Google Shape;121;p6"/>
+          <p:cNvPr id="120" name="Google Shape;120;p6"/>
           <p:cNvGrpSpPr/>
           <p:nvPr/>
         </p:nvGrpSpPr>
@@ -8970,7 +8943,7 @@
         </p:grpSpPr>
         <p:sp>
           <p:nvSpPr>
-            <p:cNvPr id="122" name="Google Shape;122;p6"/>
+            <p:cNvPr id="121" name="Google Shape;121;p6"/>
             <p:cNvSpPr/>
             <p:nvPr/>
           </p:nvSpPr>
@@ -9037,7 +9010,7 @@
         </p:sp>
         <p:sp>
           <p:nvSpPr>
-            <p:cNvPr id="123" name="Google Shape;123;p6"/>
+            <p:cNvPr id="122" name="Google Shape;122;p6"/>
             <p:cNvSpPr txBox="1"/>
             <p:nvPr/>
           </p:nvSpPr>
@@ -9144,7 +9117,7 @@
       </p:grpSp>
       <p:grpSp>
         <p:nvGrpSpPr>
-          <p:cNvPr id="124" name="Google Shape;124;p6"/>
+          <p:cNvPr id="123" name="Google Shape;123;p6"/>
           <p:cNvGrpSpPr/>
           <p:nvPr/>
         </p:nvGrpSpPr>
@@ -9158,7 +9131,7 @@
         </p:grpSpPr>
         <p:sp>
           <p:nvSpPr>
-            <p:cNvPr id="125" name="Google Shape;125;p6"/>
+            <p:cNvPr id="124" name="Google Shape;124;p6"/>
             <p:cNvSpPr/>
             <p:nvPr/>
           </p:nvSpPr>
@@ -9225,7 +9198,7 @@
         </p:sp>
         <p:sp>
           <p:nvSpPr>
-            <p:cNvPr id="126" name="Google Shape;126;p6"/>
+            <p:cNvPr id="125" name="Google Shape;125;p6"/>
             <p:cNvSpPr txBox="1"/>
             <p:nvPr/>
           </p:nvSpPr>
@@ -9356,7 +9329,7 @@
       </p:grpSp>
       <p:grpSp>
         <p:nvGrpSpPr>
-          <p:cNvPr id="127" name="Google Shape;127;p6"/>
+          <p:cNvPr id="126" name="Google Shape;126;p6"/>
           <p:cNvGrpSpPr/>
           <p:nvPr/>
         </p:nvGrpSpPr>
@@ -9370,7 +9343,7 @@
         </p:grpSpPr>
         <p:sp>
           <p:nvSpPr>
-            <p:cNvPr id="128" name="Google Shape;128;p6"/>
+            <p:cNvPr id="127" name="Google Shape;127;p6"/>
             <p:cNvSpPr/>
             <p:nvPr/>
           </p:nvSpPr>
@@ -9437,7 +9410,7 @@
         </p:sp>
         <p:sp>
           <p:nvSpPr>
-            <p:cNvPr id="129" name="Google Shape;129;p6"/>
+            <p:cNvPr id="128" name="Google Shape;128;p6"/>
             <p:cNvSpPr txBox="1"/>
             <p:nvPr/>
           </p:nvSpPr>
@@ -9586,7 +9559,7 @@
     </p:bg>
     <p:spTree>
       <p:nvGrpSpPr>
-        <p:cNvPr id="134" name="Shape 134"/>
+        <p:cNvPr id="133" name="Shape 133"/>
         <p:cNvGrpSpPr/>
         <p:nvPr/>
       </p:nvGrpSpPr>
@@ -9600,7 +9573,7 @@
       </p:grpSpPr>
       <p:pic>
         <p:nvPicPr>
-          <p:cNvPr descr="assets/logo_mark.png" id="135" name="Google Shape;135;p7"/>
+          <p:cNvPr descr="assets/logo_mark.png" id="134" name="Google Shape;134;p7"/>
           <p:cNvPicPr preferRelativeResize="0"/>
           <p:nvPr/>
         </p:nvPicPr>
@@ -9627,7 +9600,7 @@
       </p:pic>
       <p:sp>
         <p:nvSpPr>
-          <p:cNvPr id="136" name="Google Shape;136;p7"/>
+          <p:cNvPr id="135" name="Google Shape;135;p7"/>
           <p:cNvSpPr/>
           <p:nvPr/>
         </p:nvSpPr>
@@ -9693,7 +9666,7 @@
       </p:sp>
       <p:sp>
         <p:nvSpPr>
-          <p:cNvPr id="137" name="Google Shape;137;p7"/>
+          <p:cNvPr id="136" name="Google Shape;136;p7"/>
           <p:cNvSpPr/>
           <p:nvPr/>
         </p:nvSpPr>
@@ -9758,7 +9731,7 @@
       </p:sp>
       <p:sp>
         <p:nvSpPr>
-          <p:cNvPr id="138" name="Google Shape;138;p7"/>
+          <p:cNvPr id="137" name="Google Shape;137;p7"/>
           <p:cNvSpPr/>
           <p:nvPr/>
         </p:nvSpPr>
@@ -9832,7 +9805,7 @@
       </p:sp>
       <p:grpSp>
         <p:nvGrpSpPr>
-          <p:cNvPr id="139" name="Google Shape;139;p7"/>
+          <p:cNvPr id="138" name="Google Shape;138;p7"/>
           <p:cNvGrpSpPr/>
           <p:nvPr/>
         </p:nvGrpSpPr>
@@ -9846,7 +9819,7 @@
         </p:grpSpPr>
         <p:sp>
           <p:nvSpPr>
-            <p:cNvPr id="140" name="Google Shape;140;p7"/>
+            <p:cNvPr id="139" name="Google Shape;139;p7"/>
             <p:cNvSpPr/>
             <p:nvPr/>
           </p:nvSpPr>
@@ -9913,7 +9886,7 @@
         </p:sp>
         <p:sp>
           <p:nvSpPr>
-            <p:cNvPr id="141" name="Google Shape;141;p7"/>
+            <p:cNvPr id="140" name="Google Shape;140;p7"/>
             <p:cNvSpPr txBox="1"/>
             <p:nvPr/>
           </p:nvSpPr>
@@ -10020,7 +9993,7 @@
       </p:grpSp>
       <p:sp>
         <p:nvSpPr>
-          <p:cNvPr id="142" name="Google Shape;142;p7"/>
+          <p:cNvPr id="141" name="Google Shape;141;p7"/>
           <p:cNvSpPr/>
           <p:nvPr/>
         </p:nvSpPr>
@@ -10087,7 +10060,7 @@
       </p:sp>
       <p:sp>
         <p:nvSpPr>
-          <p:cNvPr id="143" name="Google Shape;143;p7"/>
+          <p:cNvPr id="142" name="Google Shape;142;p7"/>
           <p:cNvSpPr/>
           <p:nvPr/>
         </p:nvSpPr>
@@ -10169,7 +10142,7 @@
       </p:sp>
       <p:pic>
         <p:nvPicPr>
-          <p:cNvPr id="144" name="Google Shape;144;p7"/>
+          <p:cNvPr id="143" name="Google Shape;143;p7"/>
           <p:cNvPicPr preferRelativeResize="0"/>
           <p:nvPr/>
         </p:nvPicPr>
@@ -10196,7 +10169,7 @@
       </p:pic>
       <p:sp>
         <p:nvSpPr>
-          <p:cNvPr id="145" name="Google Shape;145;p7"/>
+          <p:cNvPr id="144" name="Google Shape;144;p7"/>
           <p:cNvSpPr/>
           <p:nvPr/>
         </p:nvSpPr>
@@ -10324,7 +10297,7 @@
     </p:bg>
     <p:spTree>
       <p:nvGrpSpPr>
-        <p:cNvPr id="150" name="Shape 150"/>
+        <p:cNvPr id="149" name="Shape 149"/>
         <p:cNvGrpSpPr/>
         <p:nvPr/>
       </p:nvGrpSpPr>
@@ -10338,7 +10311,7 @@
       </p:grpSpPr>
       <p:pic>
         <p:nvPicPr>
-          <p:cNvPr descr="assets/logo_mark.png" id="151" name="Google Shape;151;p8"/>
+          <p:cNvPr descr="assets/logo_mark.png" id="150" name="Google Shape;150;p8"/>
           <p:cNvPicPr preferRelativeResize="0"/>
           <p:nvPr/>
         </p:nvPicPr>
@@ -10365,7 +10338,7 @@
       </p:pic>
       <p:sp>
         <p:nvSpPr>
-          <p:cNvPr id="152" name="Google Shape;152;p8"/>
+          <p:cNvPr id="151" name="Google Shape;151;p8"/>
           <p:cNvSpPr/>
           <p:nvPr/>
         </p:nvSpPr>
@@ -10435,7 +10408,7 @@
       </p:sp>
       <p:sp>
         <p:nvSpPr>
-          <p:cNvPr id="153" name="Google Shape;153;p8"/>
+          <p:cNvPr id="152" name="Google Shape;152;p8"/>
           <p:cNvSpPr/>
           <p:nvPr/>
         </p:nvSpPr>
@@ -10500,7 +10473,7 @@
       </p:sp>
       <p:sp>
         <p:nvSpPr>
-          <p:cNvPr id="154" name="Google Shape;154;p8"/>
+          <p:cNvPr id="153" name="Google Shape;153;p8"/>
           <p:cNvSpPr/>
           <p:nvPr/>
         </p:nvSpPr>
@@ -10574,7 +10547,7 @@
       </p:sp>
       <p:sp>
         <p:nvSpPr>
-          <p:cNvPr id="155" name="Google Shape;155;p8"/>
+          <p:cNvPr id="154" name="Google Shape;154;p8"/>
           <p:cNvSpPr/>
           <p:nvPr/>
         </p:nvSpPr>
@@ -10644,7 +10617,7 @@
       </p:sp>
       <p:sp>
         <p:nvSpPr>
-          <p:cNvPr id="156" name="Google Shape;156;p8"/>
+          <p:cNvPr id="155" name="Google Shape;155;p8"/>
           <p:cNvSpPr/>
           <p:nvPr/>
         </p:nvSpPr>
@@ -10714,7 +10687,7 @@
       </p:sp>
       <p:sp>
         <p:nvSpPr>
-          <p:cNvPr id="157" name="Google Shape;157;p8"/>
+          <p:cNvPr id="156" name="Google Shape;156;p8"/>
           <p:cNvSpPr/>
           <p:nvPr/>
         </p:nvSpPr>
@@ -10788,7 +10761,7 @@
       </p:sp>
       <p:sp>
         <p:nvSpPr>
-          <p:cNvPr id="158" name="Google Shape;158;p8"/>
+          <p:cNvPr id="157" name="Google Shape;157;p8"/>
           <p:cNvSpPr/>
           <p:nvPr/>
         </p:nvSpPr>
@@ -10845,7 +10818,7 @@
       </p:sp>
       <p:sp>
         <p:nvSpPr>
-          <p:cNvPr id="159" name="Google Shape;159;p8"/>
+          <p:cNvPr id="158" name="Google Shape;158;p8"/>
           <p:cNvSpPr/>
           <p:nvPr/>
         </p:nvSpPr>
@@ -10955,7 +10928,7 @@
       </p:sp>
       <p:sp>
         <p:nvSpPr>
-          <p:cNvPr id="160" name="Google Shape;160;p8"/>
+          <p:cNvPr id="159" name="Google Shape;159;p8"/>
           <p:cNvSpPr/>
           <p:nvPr/>
         </p:nvSpPr>
@@ -11029,7 +11002,7 @@
       </p:sp>
       <p:sp>
         <p:nvSpPr>
-          <p:cNvPr id="161" name="Google Shape;161;p8"/>
+          <p:cNvPr id="160" name="Google Shape;160;p8"/>
           <p:cNvSpPr/>
           <p:nvPr/>
         </p:nvSpPr>
@@ -11086,7 +11059,7 @@
       </p:sp>
       <p:sp>
         <p:nvSpPr>
-          <p:cNvPr id="162" name="Google Shape;162;p8"/>
+          <p:cNvPr id="161" name="Google Shape;161;p8"/>
           <p:cNvSpPr/>
           <p:nvPr/>
         </p:nvSpPr>
@@ -11196,7 +11169,7 @@
       </p:sp>
       <p:sp>
         <p:nvSpPr>
-          <p:cNvPr id="163" name="Google Shape;163;p8"/>
+          <p:cNvPr id="162" name="Google Shape;162;p8"/>
           <p:cNvSpPr/>
           <p:nvPr/>
         </p:nvSpPr>
@@ -11266,7 +11239,7 @@
       </p:sp>
       <p:sp>
         <p:nvSpPr>
-          <p:cNvPr id="164" name="Google Shape;164;p8"/>
+          <p:cNvPr id="163" name="Google Shape;163;p8"/>
           <p:cNvSpPr/>
           <p:nvPr/>
         </p:nvSpPr>
@@ -11464,7 +11437,7 @@
       </p:sp>
       <p:sp>
         <p:nvSpPr>
-          <p:cNvPr id="165" name="Google Shape;165;p8"/>
+          <p:cNvPr id="164" name="Google Shape;164;p8"/>
           <p:cNvSpPr/>
           <p:nvPr/>
         </p:nvSpPr>
@@ -11531,7 +11504,7 @@
       </p:sp>
       <p:sp>
         <p:nvSpPr>
-          <p:cNvPr id="166" name="Google Shape;166;p8"/>
+          <p:cNvPr id="165" name="Google Shape;165;p8"/>
           <p:cNvSpPr/>
           <p:nvPr/>
         </p:nvSpPr>

</xml_diff>

<commit_message>
fix(tinder): suppression du label technique bucket et ajout des pourcentages sur le plot Q3
</commit_message>
<xml_diff>
--- a/Bloc_2_Analyse_Exploratoire/Tinder/Tinder_presentation.pptx
+++ b/Bloc_2_Analyse_Exploratoire/Tinder/Tinder_presentation.pptx
@@ -271,7 +271,7 @@
   </p:defaultTextStyle>
   <p:extLst>
     <p:ext uri="GoogleSlidesCustomDataVersion2">
-      <go:slidesCustomData xmlns:go="http://customooxmlschemas.google.com/" r:id="rId23" roundtripDataSignature="AMtx7mg5APeFNvRUeYeaiuYcqxSyDkHhNQ=="/>
+      <go:slidesCustomData xmlns:go="http://customooxmlschemas.google.com/" r:id="rId23" roundtripDataSignature="AMtx7mh6A7Gkoi13sWRPjkar1/1inPJA7g=="/>
     </p:ext>
   </p:extLst>
 </p:presentation>
@@ -1341,7 +1341,7 @@
   <p:cSld>
     <p:spTree>
       <p:nvGrpSpPr>
-        <p:cNvPr id="71" name="Shape 71"/>
+        <p:cNvPr id="72" name="Shape 72"/>
         <p:cNvGrpSpPr/>
         <p:nvPr/>
       </p:nvGrpSpPr>
@@ -1355,7 +1355,7 @@
       </p:grpSpPr>
       <p:sp>
         <p:nvSpPr>
-          <p:cNvPr id="72" name="Google Shape;72;p4:notes"/>
+          <p:cNvPr id="73" name="Google Shape;73;p4:notes"/>
           <p:cNvSpPr/>
           <p:nvPr>
             <p:ph idx="2" type="sldImg"/>
@@ -1394,7 +1394,7 @@
       </p:sp>
       <p:sp>
         <p:nvSpPr>
-          <p:cNvPr id="73" name="Google Shape;73;p4:notes"/>
+          <p:cNvPr id="74" name="Google Shape;74;p4:notes"/>
           <p:cNvSpPr txBox="1"/>
           <p:nvPr>
             <p:ph idx="1" type="body"/>
@@ -1449,7 +1449,7 @@
       </p:sp>
       <p:sp>
         <p:nvSpPr>
-          <p:cNvPr id="74" name="Google Shape;74;p4:notes"/>
+          <p:cNvPr id="75" name="Google Shape;75;p4:notes"/>
           <p:cNvSpPr txBox="1"/>
           <p:nvPr>
             <p:ph idx="12" type="sldNum"/>
@@ -1528,7 +1528,7 @@
   <p:cSld>
     <p:spTree>
       <p:nvGrpSpPr>
-        <p:cNvPr id="93" name="Shape 93"/>
+        <p:cNvPr id="94" name="Shape 94"/>
         <p:cNvGrpSpPr/>
         <p:nvPr/>
       </p:nvGrpSpPr>
@@ -1542,7 +1542,7 @@
       </p:grpSpPr>
       <p:sp>
         <p:nvSpPr>
-          <p:cNvPr id="94" name="Google Shape;94;p5:notes"/>
+          <p:cNvPr id="95" name="Google Shape;95;p5:notes"/>
           <p:cNvSpPr/>
           <p:nvPr>
             <p:ph idx="2" type="sldImg"/>
@@ -1581,7 +1581,7 @@
       </p:sp>
       <p:sp>
         <p:nvSpPr>
-          <p:cNvPr id="95" name="Google Shape;95;p5:notes"/>
+          <p:cNvPr id="96" name="Google Shape;96;p5:notes"/>
           <p:cNvSpPr txBox="1"/>
           <p:nvPr>
             <p:ph idx="1" type="body"/>
@@ -1636,7 +1636,7 @@
       </p:sp>
       <p:sp>
         <p:nvSpPr>
-          <p:cNvPr id="96" name="Google Shape;96;p5:notes"/>
+          <p:cNvPr id="97" name="Google Shape;97;p5:notes"/>
           <p:cNvSpPr txBox="1"/>
           <p:nvPr>
             <p:ph idx="12" type="sldNum"/>
@@ -1715,7 +1715,7 @@
   <p:cSld>
     <p:spTree>
       <p:nvGrpSpPr>
-        <p:cNvPr id="110" name="Shape 110"/>
+        <p:cNvPr id="111" name="Shape 111"/>
         <p:cNvGrpSpPr/>
         <p:nvPr/>
       </p:nvGrpSpPr>
@@ -1729,7 +1729,7 @@
       </p:grpSpPr>
       <p:sp>
         <p:nvSpPr>
-          <p:cNvPr id="111" name="Google Shape;111;p6:notes"/>
+          <p:cNvPr id="112" name="Google Shape;112;p6:notes"/>
           <p:cNvSpPr/>
           <p:nvPr>
             <p:ph idx="2" type="sldImg"/>
@@ -1768,7 +1768,7 @@
       </p:sp>
       <p:sp>
         <p:nvSpPr>
-          <p:cNvPr id="112" name="Google Shape;112;p6:notes"/>
+          <p:cNvPr id="113" name="Google Shape;113;p6:notes"/>
           <p:cNvSpPr txBox="1"/>
           <p:nvPr>
             <p:ph idx="1" type="body"/>
@@ -1823,7 +1823,7 @@
       </p:sp>
       <p:sp>
         <p:nvSpPr>
-          <p:cNvPr id="113" name="Google Shape;113;p6:notes"/>
+          <p:cNvPr id="114" name="Google Shape;114;p6:notes"/>
           <p:cNvSpPr txBox="1"/>
           <p:nvPr>
             <p:ph idx="12" type="sldNum"/>
@@ -1902,7 +1902,7 @@
   <p:cSld>
     <p:spTree>
       <p:nvGrpSpPr>
-        <p:cNvPr id="129" name="Shape 129"/>
+        <p:cNvPr id="130" name="Shape 130"/>
         <p:cNvGrpSpPr/>
         <p:nvPr/>
       </p:nvGrpSpPr>
@@ -1916,7 +1916,7 @@
       </p:grpSpPr>
       <p:sp>
         <p:nvSpPr>
-          <p:cNvPr id="130" name="Google Shape;130;p7:notes"/>
+          <p:cNvPr id="131" name="Google Shape;131;p7:notes"/>
           <p:cNvSpPr/>
           <p:nvPr>
             <p:ph idx="2" type="sldImg"/>
@@ -1955,7 +1955,7 @@
       </p:sp>
       <p:sp>
         <p:nvSpPr>
-          <p:cNvPr id="131" name="Google Shape;131;p7:notes"/>
+          <p:cNvPr id="132" name="Google Shape;132;p7:notes"/>
           <p:cNvSpPr txBox="1"/>
           <p:nvPr>
             <p:ph idx="1" type="body"/>
@@ -2010,7 +2010,7 @@
       </p:sp>
       <p:sp>
         <p:nvSpPr>
-          <p:cNvPr id="132" name="Google Shape;132;p7:notes"/>
+          <p:cNvPr id="133" name="Google Shape;133;p7:notes"/>
           <p:cNvSpPr txBox="1"/>
           <p:nvPr>
             <p:ph idx="12" type="sldNum"/>
@@ -2089,7 +2089,7 @@
   <p:cSld>
     <p:spTree>
       <p:nvGrpSpPr>
-        <p:cNvPr id="145" name="Shape 145"/>
+        <p:cNvPr id="146" name="Shape 146"/>
         <p:cNvGrpSpPr/>
         <p:nvPr/>
       </p:nvGrpSpPr>
@@ -2103,7 +2103,7 @@
       </p:grpSpPr>
       <p:sp>
         <p:nvSpPr>
-          <p:cNvPr id="146" name="Google Shape;146;p8:notes"/>
+          <p:cNvPr id="147" name="Google Shape;147;p8:notes"/>
           <p:cNvSpPr/>
           <p:nvPr>
             <p:ph idx="2" type="sldImg"/>
@@ -2142,7 +2142,7 @@
       </p:sp>
       <p:sp>
         <p:nvSpPr>
-          <p:cNvPr id="147" name="Google Shape;147;p8:notes"/>
+          <p:cNvPr id="148" name="Google Shape;148;p8:notes"/>
           <p:cNvSpPr txBox="1"/>
           <p:nvPr>
             <p:ph idx="1" type="body"/>
@@ -2197,7 +2197,7 @@
       </p:sp>
       <p:sp>
         <p:nvSpPr>
-          <p:cNvPr id="148" name="Google Shape;148;p8:notes"/>
+          <p:cNvPr id="149" name="Google Shape;149;p8:notes"/>
           <p:cNvSpPr txBox="1"/>
           <p:nvPr>
             <p:ph idx="12" type="sldNum"/>
@@ -5999,8 +5999,8 @@
         </p:nvGrpSpPr>
         <p:grpSpPr>
           <a:xfrm>
-            <a:off x="5953125" y="1085850"/>
-            <a:ext cx="2714700" cy="1000200"/>
+            <a:off x="5953281" y="1085850"/>
+            <a:ext cx="2820573" cy="1000200"/>
             <a:chOff x="5953125" y="1085850"/>
             <a:chExt cx="2714700" cy="1000200"/>
           </a:xfrm>
@@ -6188,7 +6188,79 @@
                   <a:cs typeface="Inter"/>
                   <a:sym typeface="Inter"/>
                 </a:rPr>
-                <a:t> que les femmes (26,9 % vs 18,0 %).</a:t>
+                <a:t> que les femmes (</a:t>
+              </a:r>
+              <a:r>
+                <a:rPr lang="en-US" sz="1100">
+                  <a:solidFill>
+                    <a:srgbClr val="5B7180"/>
+                  </a:solidFill>
+                  <a:latin typeface="Inter"/>
+                  <a:ea typeface="Inter"/>
+                  <a:cs typeface="Inter"/>
+                  <a:sym typeface="Inter"/>
+                </a:rPr>
+                <a:t>27</a:t>
+              </a:r>
+              <a:r>
+                <a:rPr b="0" i="0" lang="en-US" sz="1100" u="none" cap="none" strike="noStrike">
+                  <a:solidFill>
+                    <a:srgbClr val="5B7180"/>
+                  </a:solidFill>
+                  <a:latin typeface="Inter"/>
+                  <a:ea typeface="Inter"/>
+                  <a:cs typeface="Inter"/>
+                  <a:sym typeface="Inter"/>
+                </a:rPr>
+                <a:t> % vs </a:t>
+              </a:r>
+              <a:r>
+                <a:rPr lang="en-US" sz="1100">
+                  <a:solidFill>
+                    <a:srgbClr val="5B7180"/>
+                  </a:solidFill>
+                  <a:latin typeface="Inter"/>
+                  <a:ea typeface="Inter"/>
+                  <a:cs typeface="Inter"/>
+                  <a:sym typeface="Inter"/>
+                </a:rPr>
+                <a:t>17</a:t>
+              </a:r>
+              <a:r>
+                <a:rPr b="0" i="0" lang="en-US" sz="1100" u="none" cap="none" strike="noStrike">
+                  <a:solidFill>
+                    <a:srgbClr val="5B7180"/>
+                  </a:solidFill>
+                  <a:latin typeface="Inter"/>
+                  <a:ea typeface="Inter"/>
+                  <a:cs typeface="Inter"/>
+                  <a:sym typeface="Inter"/>
+                </a:rPr>
+                <a:t>,</a:t>
+              </a:r>
+              <a:r>
+                <a:rPr lang="en-US" sz="1100">
+                  <a:solidFill>
+                    <a:srgbClr val="5B7180"/>
+                  </a:solidFill>
+                  <a:latin typeface="Inter"/>
+                  <a:ea typeface="Inter"/>
+                  <a:cs typeface="Inter"/>
+                  <a:sym typeface="Inter"/>
+                </a:rPr>
+                <a:t>9</a:t>
+              </a:r>
+              <a:r>
+                <a:rPr b="0" i="0" lang="en-US" sz="1100" u="none" cap="none" strike="noStrike">
+                  <a:solidFill>
+                    <a:srgbClr val="5B7180"/>
+                  </a:solidFill>
+                  <a:latin typeface="Inter"/>
+                  <a:ea typeface="Inter"/>
+                  <a:cs typeface="Inter"/>
+                  <a:sym typeface="Inter"/>
+                </a:rPr>
+                <a:t> %).</a:t>
               </a:r>
               <a:endParaRPr b="0" i="0" sz="1100" u="none" cap="none" strike="noStrike">
                 <a:solidFill>
@@ -6211,8 +6283,8 @@
         </p:nvGrpSpPr>
         <p:grpSpPr>
           <a:xfrm>
-            <a:off x="5953125" y="2162175"/>
-            <a:ext cx="2714700" cy="1000200"/>
+            <a:off x="5953121" y="2162175"/>
+            <a:ext cx="2820573" cy="1000200"/>
             <a:chOff x="5953125" y="2162175"/>
             <a:chExt cx="2714700" cy="1000200"/>
           </a:xfrm>
@@ -6400,7 +6472,55 @@
                   <a:cs typeface="Inter"/>
                   <a:sym typeface="Inter"/>
                 </a:rPr>
-                <a:t> (21,0 % et 18,3 %).</a:t>
+                <a:t> (2</a:t>
+              </a:r>
+              <a:r>
+                <a:rPr lang="en-US" sz="1100">
+                  <a:solidFill>
+                    <a:srgbClr val="5B7180"/>
+                  </a:solidFill>
+                  <a:latin typeface="Inter"/>
+                  <a:ea typeface="Inter"/>
+                  <a:cs typeface="Inter"/>
+                  <a:sym typeface="Inter"/>
+                </a:rPr>
+                <a:t>0</a:t>
+              </a:r>
+              <a:r>
+                <a:rPr b="0" i="0" lang="en-US" sz="1100" u="none" cap="none" strike="noStrike">
+                  <a:solidFill>
+                    <a:srgbClr val="5B7180"/>
+                  </a:solidFill>
+                  <a:latin typeface="Inter"/>
+                  <a:ea typeface="Inter"/>
+                  <a:cs typeface="Inter"/>
+                  <a:sym typeface="Inter"/>
+                </a:rPr>
+                <a:t>,</a:t>
+              </a:r>
+              <a:r>
+                <a:rPr lang="en-US" sz="1100">
+                  <a:solidFill>
+                    <a:srgbClr val="5B7180"/>
+                  </a:solidFill>
+                  <a:latin typeface="Inter"/>
+                  <a:ea typeface="Inter"/>
+                  <a:cs typeface="Inter"/>
+                  <a:sym typeface="Inter"/>
+                </a:rPr>
+                <a:t>9</a:t>
+              </a:r>
+              <a:r>
+                <a:rPr b="0" i="0" lang="en-US" sz="1100" u="none" cap="none" strike="noStrike">
+                  <a:solidFill>
+                    <a:srgbClr val="5B7180"/>
+                  </a:solidFill>
+                  <a:latin typeface="Inter"/>
+                  <a:ea typeface="Inter"/>
+                  <a:cs typeface="Inter"/>
+                  <a:sym typeface="Inter"/>
+                </a:rPr>
+                <a:t> % et 18,3 %).</a:t>
               </a:r>
               <a:endParaRPr b="0" i="0" sz="1100" u="none" cap="none" strike="noStrike">
                 <a:solidFill>
@@ -6423,8 +6543,8 @@
         </p:nvGrpSpPr>
         <p:grpSpPr>
           <a:xfrm>
-            <a:off x="5953125" y="3238500"/>
-            <a:ext cx="2714700" cy="809700"/>
+            <a:off x="5953121" y="3238500"/>
+            <a:ext cx="2820573" cy="809700"/>
             <a:chOff x="5953125" y="3238500"/>
             <a:chExt cx="2714700" cy="809700"/>
           </a:xfrm>
@@ -6579,7 +6699,7 @@
                 <a:buNone/>
               </a:pPr>
               <a:r>
-                <a:rPr b="0" i="0" lang="en-US" sz="1100" u="none" cap="none" strike="noStrike">
+                <a:rPr lang="en-US" sz="1100">
                   <a:solidFill>
                     <a:srgbClr val="5B7180"/>
                   </a:solidFill>
@@ -6588,31 +6708,7 @@
                   <a:cs typeface="Inter"/>
                   <a:sym typeface="Inter"/>
                 </a:rPr>
-                <a:t>Le critère le moins avoué par les deux genres (</a:t>
-              </a:r>
-              <a:r>
-                <a:rPr b="1" i="0" lang="en-US" sz="1100" u="none" cap="none" strike="noStrike">
-                  <a:solidFill>
-                    <a:srgbClr val="0E3449"/>
-                  </a:solidFill>
-                  <a:latin typeface="Inter"/>
-                  <a:ea typeface="Inter"/>
-                  <a:cs typeface="Inter"/>
-                  <a:sym typeface="Inter"/>
-                </a:rPr>
-                <a:t>~8 %</a:t>
-              </a:r>
-              <a:r>
-                <a:rPr b="0" i="0" lang="en-US" sz="1100" u="none" cap="none" strike="noStrike">
-                  <a:solidFill>
-                    <a:srgbClr val="5B7180"/>
-                  </a:solidFill>
-                  <a:latin typeface="Inter"/>
-                  <a:ea typeface="Inter"/>
-                  <a:cs typeface="Inter"/>
-                  <a:sym typeface="Inter"/>
-                </a:rPr>
-                <a:t>).</a:t>
+                <a:t>Délaissée chez les hommes (8,7 %, leur dernier critère), mais valorisée par les femmes (12,8 %)</a:t>
               </a:r>
               <a:endParaRPr b="0" i="0" sz="1100" u="none" cap="none" strike="noStrike">
                 <a:solidFill>
@@ -6772,6 +6868,34 @@
           </a:p>
         </p:txBody>
       </p:sp>
+      <p:pic>
+        <p:nvPicPr>
+          <p:cNvPr id="71" name="Google Shape;71;p3"/>
+          <p:cNvPicPr preferRelativeResize="0"/>
+          <p:nvPr/>
+        </p:nvPicPr>
+        <p:blipFill>
+          <a:blip r:embed="rId4">
+            <a:alphaModFix/>
+          </a:blip>
+          <a:stretch>
+            <a:fillRect/>
+          </a:stretch>
+        </p:blipFill>
+        <p:spPr>
+          <a:xfrm>
+            <a:off x="152400" y="1085148"/>
+            <a:ext cx="5648324" cy="2469155"/>
+          </a:xfrm>
+          <a:prstGeom prst="rect">
+            <a:avLst/>
+          </a:prstGeom>
+          <a:noFill/>
+          <a:ln>
+            <a:noFill/>
+          </a:ln>
+        </p:spPr>
+      </p:pic>
     </p:spTree>
   </p:cSld>
   <p:clrMapOvr>
@@ -6792,7 +6916,7 @@
     </p:bg>
     <p:spTree>
       <p:nvGrpSpPr>
-        <p:cNvPr id="75" name="Shape 75"/>
+        <p:cNvPr id="76" name="Shape 76"/>
         <p:cNvGrpSpPr/>
         <p:nvPr/>
       </p:nvGrpSpPr>
@@ -6806,7 +6930,7 @@
       </p:grpSpPr>
       <p:pic>
         <p:nvPicPr>
-          <p:cNvPr descr="assets/logo_mark.png" id="76" name="Google Shape;76;p4"/>
+          <p:cNvPr descr="assets/logo_mark.png" id="77" name="Google Shape;77;p4"/>
           <p:cNvPicPr preferRelativeResize="0"/>
           <p:nvPr/>
         </p:nvPicPr>
@@ -6821,33 +6945,6 @@
           <a:xfrm>
             <a:off x="466344" y="457200"/>
             <a:ext cx="576072" cy="384048"/>
-          </a:xfrm>
-          <a:prstGeom prst="rect">
-            <a:avLst/>
-          </a:prstGeom>
-          <a:noFill/>
-          <a:ln>
-            <a:noFill/>
-          </a:ln>
-        </p:spPr>
-      </p:pic>
-      <p:pic>
-        <p:nvPicPr>
-          <p:cNvPr id="77" name="Google Shape;77;p4"/>
-          <p:cNvPicPr preferRelativeResize="0"/>
-          <p:nvPr/>
-        </p:nvPicPr>
-        <p:blipFill rotWithShape="1">
-          <a:blip r:embed="rId4">
-            <a:alphaModFix/>
-          </a:blip>
-          <a:srcRect b="60" l="0" r="0" t="50"/>
-          <a:stretch/>
-        </p:blipFill>
-        <p:spPr>
-          <a:xfrm>
-            <a:off x="152400" y="1095375"/>
-            <a:ext cx="5334000" cy="2305200"/>
           </a:xfrm>
           <a:prstGeom prst="rect">
             <a:avLst/>
@@ -7228,7 +7325,79 @@
                   <a:cs typeface="Inter"/>
                   <a:sym typeface="Inter"/>
                 </a:rPr>
-                <a:t>Le physique n'était que 3ᵉ dans les déclarations (22,5 %).</a:t>
+                <a:t>Le physique n'était que 3ᵉ dans les déclarations </a:t>
+              </a:r>
+              <a:r>
+                <a:rPr lang="en-US" sz="1000">
+                  <a:solidFill>
+                    <a:srgbClr val="5B7180"/>
+                  </a:solidFill>
+                  <a:latin typeface="Inter"/>
+                  <a:ea typeface="Inter"/>
+                  <a:cs typeface="Inter"/>
+                  <a:sym typeface="Inter"/>
+                </a:rPr>
+                <a:t>des femmes</a:t>
+              </a:r>
+              <a:r>
+                <a:rPr b="0" i="0" lang="en-US" sz="1000" u="none" cap="none" strike="noStrike">
+                  <a:solidFill>
+                    <a:srgbClr val="5B7180"/>
+                  </a:solidFill>
+                  <a:latin typeface="Inter"/>
+                  <a:ea typeface="Inter"/>
+                  <a:cs typeface="Inter"/>
+                  <a:sym typeface="Inter"/>
+                </a:rPr>
+                <a:t> (</a:t>
+              </a:r>
+              <a:r>
+                <a:rPr lang="en-US" sz="1000">
+                  <a:solidFill>
+                    <a:srgbClr val="5B7180"/>
+                  </a:solidFill>
+                  <a:latin typeface="Inter"/>
+                  <a:ea typeface="Inter"/>
+                  <a:cs typeface="Inter"/>
+                  <a:sym typeface="Inter"/>
+                </a:rPr>
+                <a:t>17</a:t>
+              </a:r>
+              <a:r>
+                <a:rPr b="0" i="0" lang="en-US" sz="1000" u="none" cap="none" strike="noStrike">
+                  <a:solidFill>
+                    <a:srgbClr val="5B7180"/>
+                  </a:solidFill>
+                  <a:latin typeface="Inter"/>
+                  <a:ea typeface="Inter"/>
+                  <a:cs typeface="Inter"/>
+                  <a:sym typeface="Inter"/>
+                </a:rPr>
+                <a:t>,</a:t>
+              </a:r>
+              <a:r>
+                <a:rPr lang="en-US" sz="1000">
+                  <a:solidFill>
+                    <a:srgbClr val="5B7180"/>
+                  </a:solidFill>
+                  <a:latin typeface="Inter"/>
+                  <a:ea typeface="Inter"/>
+                  <a:cs typeface="Inter"/>
+                  <a:sym typeface="Inter"/>
+                </a:rPr>
+                <a:t>9</a:t>
+              </a:r>
+              <a:r>
+                <a:rPr b="0" i="0" lang="en-US" sz="1000" u="none" cap="none" strike="noStrike">
+                  <a:solidFill>
+                    <a:srgbClr val="5B7180"/>
+                  </a:solidFill>
+                  <a:latin typeface="Inter"/>
+                  <a:ea typeface="Inter"/>
+                  <a:cs typeface="Inter"/>
+                  <a:sym typeface="Inter"/>
+                </a:rPr>
+                <a:t> %).</a:t>
               </a:r>
               <a:endParaRPr b="0" i="0" sz="1000" u="none" cap="none" strike="noStrike">
                 <a:solidFill>
@@ -7827,6 +7996,34 @@
           </p:txBody>
         </p:sp>
       </p:grpSp>
+      <p:pic>
+        <p:nvPicPr>
+          <p:cNvPr id="93" name="Google Shape;93;p4"/>
+          <p:cNvPicPr preferRelativeResize="0"/>
+          <p:nvPr/>
+        </p:nvPicPr>
+        <p:blipFill>
+          <a:blip r:embed="rId4">
+            <a:alphaModFix/>
+          </a:blip>
+          <a:stretch>
+            <a:fillRect/>
+          </a:stretch>
+        </p:blipFill>
+        <p:spPr>
+          <a:xfrm>
+            <a:off x="114300" y="1236785"/>
+            <a:ext cx="5410200" cy="1844296"/>
+          </a:xfrm>
+          <a:prstGeom prst="rect">
+            <a:avLst/>
+          </a:prstGeom>
+          <a:noFill/>
+          <a:ln>
+            <a:noFill/>
+          </a:ln>
+        </p:spPr>
+      </p:pic>
     </p:spTree>
   </p:cSld>
   <p:clrMapOvr>
@@ -7847,7 +8044,7 @@
     </p:bg>
     <p:spTree>
       <p:nvGrpSpPr>
-        <p:cNvPr id="97" name="Shape 97"/>
+        <p:cNvPr id="98" name="Shape 98"/>
         <p:cNvGrpSpPr/>
         <p:nvPr/>
       </p:nvGrpSpPr>
@@ -7861,7 +8058,7 @@
       </p:grpSpPr>
       <p:pic>
         <p:nvPicPr>
-          <p:cNvPr descr="assets/logo_mark.png" id="98" name="Google Shape;98;p5"/>
+          <p:cNvPr descr="assets/logo_mark.png" id="99" name="Google Shape;99;p5"/>
           <p:cNvPicPr preferRelativeResize="0"/>
           <p:nvPr/>
         </p:nvPicPr>
@@ -7888,7 +8085,7 @@
       </p:pic>
       <p:sp>
         <p:nvSpPr>
-          <p:cNvPr id="99" name="Google Shape;99;p5"/>
+          <p:cNvPr id="100" name="Google Shape;100;p5"/>
           <p:cNvSpPr/>
           <p:nvPr/>
         </p:nvSpPr>
@@ -7954,7 +8151,7 @@
       </p:sp>
       <p:sp>
         <p:nvSpPr>
-          <p:cNvPr id="100" name="Google Shape;100;p5"/>
+          <p:cNvPr id="101" name="Google Shape;101;p5"/>
           <p:cNvSpPr/>
           <p:nvPr/>
         </p:nvSpPr>
@@ -8019,7 +8216,7 @@
       </p:sp>
       <p:grpSp>
         <p:nvGrpSpPr>
-          <p:cNvPr id="101" name="Google Shape;101;p5"/>
+          <p:cNvPr id="102" name="Google Shape;102;p5"/>
           <p:cNvGrpSpPr/>
           <p:nvPr/>
         </p:nvGrpSpPr>
@@ -8033,7 +8230,7 @@
         </p:grpSpPr>
         <p:sp>
           <p:nvSpPr>
-            <p:cNvPr id="102" name="Google Shape;102;p5"/>
+            <p:cNvPr id="103" name="Google Shape;103;p5"/>
             <p:cNvSpPr/>
             <p:nvPr/>
           </p:nvSpPr>
@@ -8100,7 +8297,7 @@
         </p:sp>
         <p:sp>
           <p:nvSpPr>
-            <p:cNvPr id="103" name="Google Shape;103;p5"/>
+            <p:cNvPr id="104" name="Google Shape;104;p5"/>
             <p:cNvSpPr txBox="1"/>
             <p:nvPr/>
           </p:nvSpPr>
@@ -8247,7 +8444,7 @@
       </p:grpSp>
       <p:grpSp>
         <p:nvGrpSpPr>
-          <p:cNvPr id="104" name="Google Shape;104;p5"/>
+          <p:cNvPr id="105" name="Google Shape;105;p5"/>
           <p:cNvGrpSpPr/>
           <p:nvPr/>
         </p:nvGrpSpPr>
@@ -8261,7 +8458,7 @@
         </p:grpSpPr>
         <p:sp>
           <p:nvSpPr>
-            <p:cNvPr id="105" name="Google Shape;105;p5"/>
+            <p:cNvPr id="106" name="Google Shape;106;p5"/>
             <p:cNvSpPr/>
             <p:nvPr/>
           </p:nvSpPr>
@@ -8328,7 +8525,7 @@
         </p:sp>
         <p:sp>
           <p:nvSpPr>
-            <p:cNvPr id="106" name="Google Shape;106;p5"/>
+            <p:cNvPr id="107" name="Google Shape;107;p5"/>
             <p:cNvSpPr txBox="1"/>
             <p:nvPr/>
           </p:nvSpPr>
@@ -8458,7 +8655,7 @@
                   <a:cs typeface="Inter"/>
                   <a:sym typeface="Inter"/>
                 </a:rPr>
-                <a:t>, de 14,7 % à 19,25% de match.</a:t>
+                <a:t>, de 14,7 % à 19,5% de match.</a:t>
               </a:r>
               <a:endParaRPr b="0" i="0" sz="1100" u="none" cap="none" strike="noStrike">
                 <a:solidFill>
@@ -8475,7 +8672,7 @@
       </p:grpSp>
       <p:sp>
         <p:nvSpPr>
-          <p:cNvPr id="107" name="Google Shape;107;p5"/>
+          <p:cNvPr id="108" name="Google Shape;108;p5"/>
           <p:cNvSpPr/>
           <p:nvPr/>
         </p:nvSpPr>
@@ -8542,7 +8739,7 @@
       </p:sp>
       <p:sp>
         <p:nvSpPr>
-          <p:cNvPr id="108" name="Google Shape;108;p5"/>
+          <p:cNvPr id="109" name="Google Shape;109;p5"/>
           <p:cNvSpPr txBox="1"/>
           <p:nvPr/>
         </p:nvSpPr>
@@ -8624,21 +8821,22 @@
       </p:sp>
       <p:pic>
         <p:nvPicPr>
-          <p:cNvPr id="109" name="Google Shape;109;p5"/>
+          <p:cNvPr id="110" name="Google Shape;110;p5"/>
           <p:cNvPicPr preferRelativeResize="0"/>
           <p:nvPr/>
         </p:nvPicPr>
-        <p:blipFill rotWithShape="1">
+        <p:blipFill>
           <a:blip r:embed="rId4">
             <a:alphaModFix/>
           </a:blip>
-          <a:srcRect b="0" l="0" r="0" t="0"/>
-          <a:stretch/>
+          <a:stretch>
+            <a:fillRect/>
+          </a:stretch>
         </p:blipFill>
         <p:spPr>
           <a:xfrm>
-            <a:off x="151921" y="1019161"/>
-            <a:ext cx="5944079" cy="2695740"/>
+            <a:off x="466350" y="1380478"/>
+            <a:ext cx="5364426" cy="1985550"/>
           </a:xfrm>
           <a:prstGeom prst="rect">
             <a:avLst/>
@@ -8669,7 +8867,7 @@
     </p:bg>
     <p:spTree>
       <p:nvGrpSpPr>
-        <p:cNvPr id="114" name="Shape 114"/>
+        <p:cNvPr id="115" name="Shape 115"/>
         <p:cNvGrpSpPr/>
         <p:nvPr/>
       </p:nvGrpSpPr>
@@ -8683,7 +8881,7 @@
       </p:grpSpPr>
       <p:pic>
         <p:nvPicPr>
-          <p:cNvPr descr="assets/logo_mark.png" id="115" name="Google Shape;115;p6"/>
+          <p:cNvPr descr="assets/logo_mark.png" id="116" name="Google Shape;116;p6"/>
           <p:cNvPicPr preferRelativeResize="0"/>
           <p:nvPr/>
         </p:nvPicPr>
@@ -8710,7 +8908,7 @@
       </p:pic>
       <p:sp>
         <p:nvSpPr>
-          <p:cNvPr id="116" name="Google Shape;116;p6"/>
+          <p:cNvPr id="117" name="Google Shape;117;p6"/>
           <p:cNvSpPr/>
           <p:nvPr/>
         </p:nvSpPr>
@@ -8780,7 +8978,7 @@
       </p:sp>
       <p:sp>
         <p:nvSpPr>
-          <p:cNvPr id="117" name="Google Shape;117;p6"/>
+          <p:cNvPr id="118" name="Google Shape;118;p6"/>
           <p:cNvSpPr/>
           <p:nvPr/>
         </p:nvSpPr>
@@ -8845,7 +9043,7 @@
       </p:sp>
       <p:sp>
         <p:nvSpPr>
-          <p:cNvPr id="118" name="Google Shape;118;p6"/>
+          <p:cNvPr id="119" name="Google Shape;119;p6"/>
           <p:cNvSpPr/>
           <p:nvPr/>
         </p:nvSpPr>
@@ -8900,33 +9098,6 @@
           </a:p>
         </p:txBody>
       </p:sp>
-      <p:pic>
-        <p:nvPicPr>
-          <p:cNvPr id="119" name="Google Shape;119;p6"/>
-          <p:cNvPicPr preferRelativeResize="0"/>
-          <p:nvPr/>
-        </p:nvPicPr>
-        <p:blipFill rotWithShape="1">
-          <a:blip r:embed="rId4">
-            <a:alphaModFix/>
-          </a:blip>
-          <a:srcRect b="10" l="0" r="0" t="20"/>
-          <a:stretch/>
-        </p:blipFill>
-        <p:spPr>
-          <a:xfrm>
-            <a:off x="457200" y="1095375"/>
-            <a:ext cx="4953000" cy="3476700"/>
-          </a:xfrm>
-          <a:prstGeom prst="rect">
-            <a:avLst/>
-          </a:prstGeom>
-          <a:noFill/>
-          <a:ln>
-            <a:noFill/>
-          </a:ln>
-        </p:spPr>
-      </p:pic>
       <p:grpSp>
         <p:nvGrpSpPr>
           <p:cNvPr id="120" name="Google Shape;120;p6"/>
@@ -9500,7 +9671,7 @@
                   <a:cs typeface="Inter"/>
                   <a:sym typeface="Inter"/>
                 </a:rPr>
-                <a:t>Se sur estiment en moyenne de </a:t>
+                <a:t>Se surestiment en moyenne de </a:t>
               </a:r>
               <a:r>
                 <a:rPr b="1" i="0" lang="en-US" sz="1000" u="none" cap="none" strike="noStrike">
@@ -9539,6 +9710,34 @@
           </p:txBody>
         </p:sp>
       </p:grpSp>
+      <p:pic>
+        <p:nvPicPr>
+          <p:cNvPr id="129" name="Google Shape;129;p6"/>
+          <p:cNvPicPr preferRelativeResize="0"/>
+          <p:nvPr/>
+        </p:nvPicPr>
+        <p:blipFill>
+          <a:blip r:embed="rId4">
+            <a:alphaModFix/>
+          </a:blip>
+          <a:stretch>
+            <a:fillRect/>
+          </a:stretch>
+        </p:blipFill>
+        <p:spPr>
+          <a:xfrm>
+            <a:off x="628500" y="1075213"/>
+            <a:ext cx="4972715" cy="3674363"/>
+          </a:xfrm>
+          <a:prstGeom prst="rect">
+            <a:avLst/>
+          </a:prstGeom>
+          <a:noFill/>
+          <a:ln>
+            <a:noFill/>
+          </a:ln>
+        </p:spPr>
+      </p:pic>
     </p:spTree>
   </p:cSld>
   <p:clrMapOvr>
@@ -9559,7 +9758,7 @@
     </p:bg>
     <p:spTree>
       <p:nvGrpSpPr>
-        <p:cNvPr id="133" name="Shape 133"/>
+        <p:cNvPr id="134" name="Shape 134"/>
         <p:cNvGrpSpPr/>
         <p:nvPr/>
       </p:nvGrpSpPr>
@@ -9573,7 +9772,7 @@
       </p:grpSpPr>
       <p:pic>
         <p:nvPicPr>
-          <p:cNvPr descr="assets/logo_mark.png" id="134" name="Google Shape;134;p7"/>
+          <p:cNvPr descr="assets/logo_mark.png" id="135" name="Google Shape;135;p7"/>
           <p:cNvPicPr preferRelativeResize="0"/>
           <p:nvPr/>
         </p:nvPicPr>
@@ -9600,7 +9799,7 @@
       </p:pic>
       <p:sp>
         <p:nvSpPr>
-          <p:cNvPr id="135" name="Google Shape;135;p7"/>
+          <p:cNvPr id="136" name="Google Shape;136;p7"/>
           <p:cNvSpPr/>
           <p:nvPr/>
         </p:nvSpPr>
@@ -9666,7 +9865,7 @@
       </p:sp>
       <p:sp>
         <p:nvSpPr>
-          <p:cNvPr id="136" name="Google Shape;136;p7"/>
+          <p:cNvPr id="137" name="Google Shape;137;p7"/>
           <p:cNvSpPr/>
           <p:nvPr/>
         </p:nvSpPr>
@@ -9731,7 +9930,7 @@
       </p:sp>
       <p:sp>
         <p:nvSpPr>
-          <p:cNvPr id="137" name="Google Shape;137;p7"/>
+          <p:cNvPr id="138" name="Google Shape;138;p7"/>
           <p:cNvSpPr/>
           <p:nvPr/>
         </p:nvSpPr>
@@ -9805,7 +10004,7 @@
       </p:sp>
       <p:grpSp>
         <p:nvGrpSpPr>
-          <p:cNvPr id="138" name="Google Shape;138;p7"/>
+          <p:cNvPr id="139" name="Google Shape;139;p7"/>
           <p:cNvGrpSpPr/>
           <p:nvPr/>
         </p:nvGrpSpPr>
@@ -9819,7 +10018,7 @@
         </p:grpSpPr>
         <p:sp>
           <p:nvSpPr>
-            <p:cNvPr id="139" name="Google Shape;139;p7"/>
+            <p:cNvPr id="140" name="Google Shape;140;p7"/>
             <p:cNvSpPr/>
             <p:nvPr/>
           </p:nvSpPr>
@@ -9886,7 +10085,7 @@
         </p:sp>
         <p:sp>
           <p:nvSpPr>
-            <p:cNvPr id="140" name="Google Shape;140;p7"/>
+            <p:cNvPr id="141" name="Google Shape;141;p7"/>
             <p:cNvSpPr txBox="1"/>
             <p:nvPr/>
           </p:nvSpPr>
@@ -9993,7 +10192,7 @@
       </p:grpSp>
       <p:sp>
         <p:nvSpPr>
-          <p:cNvPr id="141" name="Google Shape;141;p7"/>
+          <p:cNvPr id="142" name="Google Shape;142;p7"/>
           <p:cNvSpPr/>
           <p:nvPr/>
         </p:nvSpPr>
@@ -10060,7 +10259,7 @@
       </p:sp>
       <p:sp>
         <p:nvSpPr>
-          <p:cNvPr id="142" name="Google Shape;142;p7"/>
+          <p:cNvPr id="143" name="Google Shape;143;p7"/>
           <p:cNvSpPr/>
           <p:nvPr/>
         </p:nvSpPr>
@@ -10140,33 +10339,6 @@
           </a:p>
         </p:txBody>
       </p:sp>
-      <p:pic>
-        <p:nvPicPr>
-          <p:cNvPr id="143" name="Google Shape;143;p7"/>
-          <p:cNvPicPr preferRelativeResize="0"/>
-          <p:nvPr/>
-        </p:nvPicPr>
-        <p:blipFill rotWithShape="1">
-          <a:blip r:embed="rId4">
-            <a:alphaModFix/>
-          </a:blip>
-          <a:srcRect b="0" l="1239" r="1239" t="0"/>
-          <a:stretch/>
-        </p:blipFill>
-        <p:spPr>
-          <a:xfrm>
-            <a:off x="457200" y="1143000"/>
-            <a:ext cx="4953000" cy="2514600"/>
-          </a:xfrm>
-          <a:prstGeom prst="rect">
-            <a:avLst/>
-          </a:prstGeom>
-          <a:noFill/>
-          <a:ln>
-            <a:noFill/>
-          </a:ln>
-        </p:spPr>
-      </p:pic>
       <p:sp>
         <p:nvSpPr>
           <p:cNvPr id="144" name="Google Shape;144;p7"/>
@@ -10277,6 +10449,34 @@
           </a:p>
         </p:txBody>
       </p:sp>
+      <p:pic>
+        <p:nvPicPr>
+          <p:cNvPr id="145" name="Google Shape;145;p7"/>
+          <p:cNvPicPr preferRelativeResize="0"/>
+          <p:nvPr/>
+        </p:nvPicPr>
+        <p:blipFill>
+          <a:blip r:embed="rId4">
+            <a:alphaModFix/>
+          </a:blip>
+          <a:stretch>
+            <a:fillRect/>
+          </a:stretch>
+        </p:blipFill>
+        <p:spPr>
+          <a:xfrm>
+            <a:off x="152400" y="1085148"/>
+            <a:ext cx="5410201" cy="2365060"/>
+          </a:xfrm>
+          <a:prstGeom prst="rect">
+            <a:avLst/>
+          </a:prstGeom>
+          <a:noFill/>
+          <a:ln>
+            <a:noFill/>
+          </a:ln>
+        </p:spPr>
+      </p:pic>
     </p:spTree>
   </p:cSld>
   <p:clrMapOvr>
@@ -10297,7 +10497,7 @@
     </p:bg>
     <p:spTree>
       <p:nvGrpSpPr>
-        <p:cNvPr id="149" name="Shape 149"/>
+        <p:cNvPr id="150" name="Shape 150"/>
         <p:cNvGrpSpPr/>
         <p:nvPr/>
       </p:nvGrpSpPr>
@@ -10311,7 +10511,7 @@
       </p:grpSpPr>
       <p:pic>
         <p:nvPicPr>
-          <p:cNvPr descr="assets/logo_mark.png" id="150" name="Google Shape;150;p8"/>
+          <p:cNvPr descr="assets/logo_mark.png" id="151" name="Google Shape;151;p8"/>
           <p:cNvPicPr preferRelativeResize="0"/>
           <p:nvPr/>
         </p:nvPicPr>
@@ -10338,7 +10538,7 @@
       </p:pic>
       <p:sp>
         <p:nvSpPr>
-          <p:cNvPr id="151" name="Google Shape;151;p8"/>
+          <p:cNvPr id="152" name="Google Shape;152;p8"/>
           <p:cNvSpPr/>
           <p:nvPr/>
         </p:nvSpPr>
@@ -10408,7 +10608,7 @@
       </p:sp>
       <p:sp>
         <p:nvSpPr>
-          <p:cNvPr id="152" name="Google Shape;152;p8"/>
+          <p:cNvPr id="153" name="Google Shape;153;p8"/>
           <p:cNvSpPr/>
           <p:nvPr/>
         </p:nvSpPr>
@@ -10473,7 +10673,7 @@
       </p:sp>
       <p:sp>
         <p:nvSpPr>
-          <p:cNvPr id="153" name="Google Shape;153;p8"/>
+          <p:cNvPr id="154" name="Google Shape;154;p8"/>
           <p:cNvSpPr/>
           <p:nvPr/>
         </p:nvSpPr>
@@ -10547,7 +10747,7 @@
       </p:sp>
       <p:sp>
         <p:nvSpPr>
-          <p:cNvPr id="154" name="Google Shape;154;p8"/>
+          <p:cNvPr id="155" name="Google Shape;155;p8"/>
           <p:cNvSpPr/>
           <p:nvPr/>
         </p:nvSpPr>
@@ -10617,7 +10817,7 @@
       </p:sp>
       <p:sp>
         <p:nvSpPr>
-          <p:cNvPr id="155" name="Google Shape;155;p8"/>
+          <p:cNvPr id="156" name="Google Shape;156;p8"/>
           <p:cNvSpPr/>
           <p:nvPr/>
         </p:nvSpPr>
@@ -10687,7 +10887,7 @@
       </p:sp>
       <p:sp>
         <p:nvSpPr>
-          <p:cNvPr id="156" name="Google Shape;156;p8"/>
+          <p:cNvPr id="157" name="Google Shape;157;p8"/>
           <p:cNvSpPr/>
           <p:nvPr/>
         </p:nvSpPr>
@@ -10761,7 +10961,7 @@
       </p:sp>
       <p:sp>
         <p:nvSpPr>
-          <p:cNvPr id="157" name="Google Shape;157;p8"/>
+          <p:cNvPr id="158" name="Google Shape;158;p8"/>
           <p:cNvSpPr/>
           <p:nvPr/>
         </p:nvSpPr>
@@ -10818,7 +11018,7 @@
       </p:sp>
       <p:sp>
         <p:nvSpPr>
-          <p:cNvPr id="158" name="Google Shape;158;p8"/>
+          <p:cNvPr id="159" name="Google Shape;159;p8"/>
           <p:cNvSpPr/>
           <p:nvPr/>
         </p:nvSpPr>
@@ -10928,7 +11128,7 @@
       </p:sp>
       <p:sp>
         <p:nvSpPr>
-          <p:cNvPr id="159" name="Google Shape;159;p8"/>
+          <p:cNvPr id="160" name="Google Shape;160;p8"/>
           <p:cNvSpPr/>
           <p:nvPr/>
         </p:nvSpPr>
@@ -11002,7 +11202,7 @@
       </p:sp>
       <p:sp>
         <p:nvSpPr>
-          <p:cNvPr id="160" name="Google Shape;160;p8"/>
+          <p:cNvPr id="161" name="Google Shape;161;p8"/>
           <p:cNvSpPr/>
           <p:nvPr/>
         </p:nvSpPr>
@@ -11059,7 +11259,7 @@
       </p:sp>
       <p:sp>
         <p:nvSpPr>
-          <p:cNvPr id="161" name="Google Shape;161;p8"/>
+          <p:cNvPr id="162" name="Google Shape;162;p8"/>
           <p:cNvSpPr/>
           <p:nvPr/>
         </p:nvSpPr>
@@ -11169,7 +11369,7 @@
       </p:sp>
       <p:sp>
         <p:nvSpPr>
-          <p:cNvPr id="162" name="Google Shape;162;p8"/>
+          <p:cNvPr id="163" name="Google Shape;163;p8"/>
           <p:cNvSpPr/>
           <p:nvPr/>
         </p:nvSpPr>
@@ -11239,7 +11439,7 @@
       </p:sp>
       <p:sp>
         <p:nvSpPr>
-          <p:cNvPr id="163" name="Google Shape;163;p8"/>
+          <p:cNvPr id="164" name="Google Shape;164;p8"/>
           <p:cNvSpPr/>
           <p:nvPr/>
         </p:nvSpPr>
@@ -11437,7 +11637,7 @@
       </p:sp>
       <p:sp>
         <p:nvSpPr>
-          <p:cNvPr id="164" name="Google Shape;164;p8"/>
+          <p:cNvPr id="165" name="Google Shape;165;p8"/>
           <p:cNvSpPr/>
           <p:nvPr/>
         </p:nvSpPr>
@@ -11504,7 +11704,7 @@
       </p:sp>
       <p:sp>
         <p:nvSpPr>
-          <p:cNvPr id="165" name="Google Shape;165;p8"/>
+          <p:cNvPr id="166" name="Google Shape;166;p8"/>
           <p:cNvSpPr/>
           <p:nvPr/>
         </p:nvSpPr>
@@ -11593,7 +11793,7 @@
 </file>
 
 <file path=ppt/theme/theme1.xml><?xml version="1.0" encoding="utf-8"?>
-<a:theme xmlns:a="http://schemas.openxmlformats.org/drawingml/2006/main" xmlns:r="http://schemas.openxmlformats.org/officeDocument/2006/relationships" name="Thème Office">
+<a:theme xmlns:a="http://schemas.openxmlformats.org/drawingml/2006/main" xmlns:r="http://schemas.openxmlformats.org/officeDocument/2006/relationships" name="Office Theme">
   <a:themeElements>
     <a:clrScheme name="Office">
       <a:dk1>
@@ -11872,7 +12072,7 @@
 </file>
 
 <file path=ppt/theme/theme2.xml><?xml version="1.0" encoding="utf-8"?>
-<a:theme xmlns:a="http://schemas.openxmlformats.org/drawingml/2006/main" xmlns:r="http://schemas.openxmlformats.org/officeDocument/2006/relationships" name="Office Theme">
+<a:theme xmlns:a="http://schemas.openxmlformats.org/drawingml/2006/main" xmlns:r="http://schemas.openxmlformats.org/officeDocument/2006/relationships" name="Thème Office">
   <a:themeElements>
     <a:clrScheme name="Office">
       <a:dk1>

</xml_diff>

<commit_message>
docs(tinder): actualisation des visuels du README avec les sorties exactes du notebook execute
</commit_message>
<xml_diff>
--- a/Bloc_2_Analyse_Exploratoire/Tinder/Tinder_presentation.pptx
+++ b/Bloc_2_Analyse_Exploratoire/Tinder/Tinder_presentation.pptx
@@ -271,7 +271,7 @@
   </p:defaultTextStyle>
   <p:extLst>
     <p:ext uri="GoogleSlidesCustomDataVersion2">
-      <go:slidesCustomData xmlns:go="http://customooxmlschemas.google.com/" r:id="rId23" roundtripDataSignature="AMtx7mh6A7Gkoi13sWRPjkar1/1inPJA7g=="/>
+      <go:slidesCustomData xmlns:go="http://customooxmlschemas.google.com/" r:id="rId23" roundtripDataSignature="AMtx7mgNOQ59ANj+RnEelDYvZ5mDPBUiMQ=="/>
     </p:ext>
   </p:extLst>
 </p:presentation>
@@ -8835,8 +8835,8 @@
         </p:blipFill>
         <p:spPr>
           <a:xfrm>
-            <a:off x="466350" y="1380478"/>
-            <a:ext cx="5364426" cy="1985550"/>
+            <a:off x="355825" y="1270125"/>
+            <a:ext cx="5595349" cy="2071025"/>
           </a:xfrm>
           <a:prstGeom prst="rect">
             <a:avLst/>

</xml_diff>